<commit_message>
data-eng 2-1 실습점검 7장 — 4단계는 아직 치지 않음(docker run 전 exec → No such container)
Co-Authored-By: Claude Opus 5.5 <noreply@anthropic.com>
</commit_message>
<xml_diff>
--- a/data-eng/decks/w2d1s0.pptx
+++ b/data-eng/decks/w2d1s0.pptx
@@ -10626,7 +10626,7 @@
                 <a:ea typeface="Pretendard"/>
                 <a:cs typeface="Pretendard"/>
               </a:rPr>
-              <a:t>docker exec -it -e LANG=C.UTF-8 de-mysql mysql …</a:t>
+              <a:t>4단계는 아직 치지 않는다 — 순서만 확인</a:t>
             </a:r>
           </a:p>
         </p:txBody>
@@ -10667,7 +10667,7 @@
                 <a:ea typeface="Pretendard"/>
                 <a:cs typeface="Pretendard"/>
               </a:rPr>
-              <a:t>빼면 mysql&gt; 에 친 한글이 사라지고 기존 한글은 ??? 로 보인다</a:t>
+              <a:t>docker run(기동 1단계) → logs 에 port: 3306 → exec -e LANG=C.UTF-8</a:t>
             </a:r>
           </a:p>
         </p:txBody>
@@ -10742,7 +10742,7 @@
                 <a:ea typeface="Pretendard"/>
                 <a:cs typeface="Pretendard"/>
               </a:rPr>
-              <a:t>접속은</a:t>
+              <a:t>지금 exec 를 치면</a:t>
             </a:r>
           </a:p>
         </p:txBody>
@@ -10783,7 +10783,7 @@
                 <a:ea typeface="Pretendard"/>
                 <a:cs typeface="Pretendard"/>
               </a:rPr>
-              <a:t>기동과 접속</a:t>
+              <a:t>No such</a:t>
             </a:r>
           </a:p>
           <a:p>
@@ -10801,7 +10801,7 @@
                 <a:ea typeface="Pretendard"/>
                 <a:cs typeface="Pretendard"/>
               </a:rPr>
-              <a:t>3단계에서</a:t>
+              <a:t>container</a:t>
             </a:r>
           </a:p>
         </p:txBody>

</xml_diff>